<commit_message>
Adding updated ppt and readme.md file too
</commit_message>
<xml_diff>
--- a/Project_Presentation.pptx
+++ b/Project_Presentation.pptx
@@ -265,10 +265,47 @@
       <p15:sldGuideLst xmlns:p15="http://schemas.microsoft.com/office/powerpoint/2012/main"/>
     </p:ext>
     <p:ext uri="GoogleSlidesCustomDataVersion2">
-      <go:slidesCustomData xmlns:go="http://customooxmlschemas.google.com/" xmlns:ahyp="http://schemas.microsoft.com/office/drawing/2018/hyperlinkcolor" xmlns:p15="http://schemas.microsoft.com/office/powerpoint/2012/main" xmlns:p14="http://schemas.microsoft.com/office/powerpoint/2010/main" xmlns:com="http://schemas.openxmlformats.org/drawingml/2006/compatibility" xmlns:pvml="urn:schemas-microsoft-com:office:powerpoint" xmlns:v="urn:schemas-microsoft-com:vml" xmlns:o="urn:schemas-microsoft-com:office:office" xmlns:dgm="http://schemas.openxmlformats.org/drawingml/2006/diagram" xmlns:c="http://schemas.openxmlformats.org/drawingml/2006/chart" xmlns:mv="urn:schemas-microsoft-com:mac:vml" xmlns:mc="http://schemas.openxmlformats.org/markup-compatibility/2006" xmlns="" r:id="rId27" roundtripDataSignature="AMtx7mjt3491jQ7aCoyIz2WXeHKroE7tpQ=="/>
+      <go:slidesCustomData xmlns="" xmlns:mc="http://schemas.openxmlformats.org/markup-compatibility/2006" xmlns:mv="urn:schemas-microsoft-com:mac:vml" xmlns:c="http://schemas.openxmlformats.org/drawingml/2006/chart" xmlns:dgm="http://schemas.openxmlformats.org/drawingml/2006/diagram" xmlns:o="urn:schemas-microsoft-com:office:office" xmlns:v="urn:schemas-microsoft-com:vml" xmlns:pvml="urn:schemas-microsoft-com:office:powerpoint" xmlns:com="http://schemas.openxmlformats.org/drawingml/2006/compatibility" xmlns:p14="http://schemas.microsoft.com/office/powerpoint/2010/main" xmlns:p15="http://schemas.microsoft.com/office/powerpoint/2012/main" xmlns:ahyp="http://schemas.microsoft.com/office/drawing/2018/hyperlinkcolor" xmlns:go="http://customooxmlschemas.google.com/" r:id="rId27" roundtripDataSignature="AMtx7mjt3491jQ7aCoyIz2WXeHKroE7tpQ=="/>
     </p:ext>
   </p:extLst>
 </p:presentation>
+</file>
+
+<file path=ppt/revisionInfo.xml><?xml version="1.0" encoding="utf-8"?>
+<p1510:revInfo xmlns:a="http://schemas.openxmlformats.org/drawingml/2006/main" xmlns:r="http://schemas.openxmlformats.org/officeDocument/2006/relationships" xmlns:p1510="http://schemas.microsoft.com/office/powerpoint/2015/10/main">
+  <p1510:revLst>
+    <p1510:client id="{B46B545C-A46A-4364-B577-10165419BA17}" v="3" dt="2026-09-08T17:52:43.806"/>
+  </p1510:revLst>
+</p1510:revInfo>
+</file>
+
+<file path=ppt/changesInfos/changesInfo1.xml><?xml version="1.0" encoding="utf-8"?>
+<pc:chgInfo xmlns:a="http://schemas.openxmlformats.org/drawingml/2006/main" xmlns:r="http://schemas.openxmlformats.org/officeDocument/2006/relationships" xmlns:ac="http://schemas.microsoft.com/office/drawing/2013/main/command" xmlns:pc="http://schemas.microsoft.com/office/powerpoint/2013/main/command">
+  <pc:docChgLst>
+    <pc:chgData name="Naveen Sharma" userId="ace8e01f53935731" providerId="LiveId" clId="{7CF565F9-B6F0-46A3-9B04-507F30EE438D}"/>
+    <pc:docChg chg="modSld">
+      <pc:chgData name="Naveen Sharma" userId="ace8e01f53935731" providerId="LiveId" clId="{7CF565F9-B6F0-46A3-9B04-507F30EE438D}" dt="2026-09-08T17:51:34.324" v="2" actId="20578"/>
+      <pc:docMkLst>
+        <pc:docMk/>
+      </pc:docMkLst>
+      <pc:sldChg chg="modSp mod">
+        <pc:chgData name="Naveen Sharma" userId="ace8e01f53935731" providerId="LiveId" clId="{7CF565F9-B6F0-46A3-9B04-507F30EE438D}" dt="2026-09-08T17:51:34.324" v="2" actId="20578"/>
+        <pc:sldMkLst>
+          <pc:docMk/>
+          <pc:sldMk cId="4040412275" sldId="305"/>
+        </pc:sldMkLst>
+        <pc:spChg chg="mod">
+          <ac:chgData name="Naveen Sharma" userId="ace8e01f53935731" providerId="LiveId" clId="{7CF565F9-B6F0-46A3-9B04-507F30EE438D}" dt="2026-09-08T17:51:34.324" v="2" actId="20578"/>
+          <ac:spMkLst>
+            <pc:docMk/>
+            <pc:sldMk cId="4040412275" sldId="305"/>
+            <ac:spMk id="279" creationId="{3711AF54-94A6-B837-31EF-9A8C4ECB9AF6}"/>
+          </ac:spMkLst>
+        </pc:spChg>
+      </pc:sldChg>
+    </pc:docChg>
+  </pc:docChgLst>
+</pc:chgInfo>
 </file>
 
 <file path=ppt/notesMasters/notesMaster1.xml><?xml version="1.0" encoding="utf-8"?>
@@ -14503,22 +14540,14 @@
             </a:r>
           </a:p>
           <a:p>
-            <a:pPr marL="0" marR="0" lvl="0" indent="0" algn="l" rtl="0">
+            <a:pPr>
               <a:lnSpc>
                 <a:spcPct val="162162"/>
               </a:lnSpc>
-              <a:spcBef>
-                <a:spcPts val="0"/>
-              </a:spcBef>
-              <a:spcAft>
-                <a:spcPts val="0"/>
-              </a:spcAft>
               <a:buClr>
                 <a:srgbClr val="2B3541"/>
               </a:buClr>
               <a:buSzPts val="1850"/>
-              <a:buFont typeface="Times New Roman"/>
-              <a:buNone/>
             </a:pPr>
             <a:r>
               <a:rPr lang="en-US" sz="1850" dirty="0">
@@ -14556,6 +14585,28 @@
               </a:rPr>
               <a:t> URL –</a:t>
             </a:r>
+            <a:r>
+              <a:rPr lang="en-US" sz="1850" dirty="0">
+                <a:solidFill>
+                  <a:srgbClr val="2B3541"/>
+                </a:solidFill>
+                <a:latin typeface="Times New Roman"/>
+                <a:ea typeface="Times New Roman"/>
+                <a:cs typeface="Times New Roman"/>
+                <a:sym typeface="Times New Roman"/>
+                <a:hlinkClick r:id="rId3"/>
+              </a:rPr>
+              <a:t>https://github.com/naveencoding75/nutrition-agent</a:t>
+            </a:r>
+            <a:endParaRPr lang="en-US" sz="1850" dirty="0">
+              <a:solidFill>
+                <a:srgbClr val="2B3541"/>
+              </a:solidFill>
+              <a:latin typeface="Times New Roman"/>
+              <a:ea typeface="Times New Roman"/>
+              <a:cs typeface="Times New Roman"/>
+              <a:sym typeface="Times New Roman"/>
+            </a:endParaRPr>
           </a:p>
           <a:p>
             <a:pPr lvl="0">

</xml_diff>